<commit_message>
WaferEngine-staging: weekly slides — replace the prose 'what changed' page with two diagrams
The text page was too dense to read at a glance. Split into one diagram per
kernel, drawn in the palette/typography of the existing floorplan assets:

- prefill: chunk row, cold vs warm, kept prefix vs computed suffix, with the
  start_chunk boundary called out
- decode: round 1 of both arms on a shared context axis, showing the no-reuse
  arm re-decoding 256 steps it had already taken (262.9M vs 127.7M, -51.4%)

Diagram generator + SVG sources kept alongside the deck.

Co-Authored-By: Claude Opus 4.8 <noreply@anthropic.com>
Claude-Session: https://claude.ai/code/session_0195YKX5TYtr8rPzj4JnKMWq
</commit_message>
<xml_diff>
--- a/projects/WaferEngine-staging/meetings/2026-07-20.pptx
+++ b/projects/WaferEngine-staging/meetings/2026-07-20.pptx
@@ -8,9 +8,10 @@
     <p:sldId id="256" r:id="rId2"/>
     <p:sldId id="259" r:id="rId5"/>
     <p:sldId id="274" r:id="rId25"/>
-    <p:sldId id="260" r:id="rId6"/>
+    <p:sldId id="275" r:id="rId26"/>
+    <p:sldId id="276" r:id="rId27"/>
     <p:sldId id="267" r:id="rId13"/>
-    <p:sldId id="275" r:id="rId26"/>
+    <p:sldId id="277" r:id="rId28"/>
   </p:sldIdLst>
   <p:notesMasterIdLst>
     <p:notesMasterId r:id="rId20"/>
@@ -725,94 +726,6 @@
 </p:notes>
 </file>
 
-<file path=ppt/notesSlides/notesSlide5.xml><?xml version="1.0" encoding="utf-8"?>
-<p:notes xmlns:a="http://schemas.openxmlformats.org/drawingml/2006/main" xmlns:r="http://schemas.openxmlformats.org/officeDocument/2006/relationships" xmlns:p="http://schemas.openxmlformats.org/presentationml/2006/main">
-  <p:cSld>
-    <p:spTree>
-      <p:nvGrpSpPr>
-        <p:cNvPr id="1" name=""/>
-        <p:cNvGrpSpPr/>
-        <p:nvPr/>
-      </p:nvGrpSpPr>
-      <p:grpSpPr>
-        <a:xfrm>
-          <a:off x="0" y="0"/>
-          <a:ext cx="0" cy="0"/>
-          <a:chOff x="0" y="0"/>
-          <a:chExt cx="0" cy="0"/>
-        </a:xfrm>
-      </p:grpSpPr>
-      <p:sp>
-        <p:nvSpPr>
-          <p:cNvPr id="2" name="Slide Image Placeholder 1"/>
-          <p:cNvSpPr>
-            <a:spLocks noGrp="1" noRot="1" noChangeAspect="1"/>
-          </p:cNvSpPr>
-          <p:nvPr>
-            <p:ph type="sldImg"/>
-          </p:nvPr>
-        </p:nvSpPr>
-        <p:spPr/>
-      </p:sp>
-      <p:sp>
-        <p:nvSpPr>
-          <p:cNvPr id="3" name="Notes Placeholder 2"/>
-          <p:cNvSpPr>
-            <a:spLocks noGrp="1"/>
-          </p:cNvSpPr>
-          <p:nvPr>
-            <p:ph type="body" idx="1"/>
-          </p:nvPr>
-        </p:nvSpPr>
-        <p:spPr/>
-        <p:txBody>
-          <a:bodyPr/>
-          <a:lstStyle/>
-          <a:p>
-            <a:r>
-              <a:rPr lang="en-US" dirty="0"/>
-              <a:t/>
-            </a:r>
-            <a:endParaRPr lang="en-US" dirty="0"/>
-          </a:p>
-        </p:txBody>
-      </p:sp>
-      <p:sp>
-        <p:nvSpPr>
-          <p:cNvPr id="4" name="Slide Number Placeholder 3"/>
-          <p:cNvSpPr>
-            <a:spLocks noGrp="1"/>
-          </p:cNvSpPr>
-          <p:nvPr>
-            <p:ph type="sldNum" sz="quarter" idx="10"/>
-          </p:nvPr>
-        </p:nvSpPr>
-        <p:spPr/>
-        <p:txBody>
-          <a:bodyPr/>
-          <a:lstStyle/>
-          <a:p>
-            <a:fld id="{F7021451-1387-4CA6-816F-3879F97B5CBC}" type="slidenum">
-              <a:rPr lang="en-US"/>
-              <a:t>5</a:t>
-            </a:fld>
-            <a:endParaRPr lang="en-US"/>
-          </a:p>
-        </p:txBody>
-      </p:sp>
-    </p:spTree>
-    <p:extLst>
-      <p:ext uri="{BB962C8B-B14F-4D97-AF65-F5344CB8AC3E}">
-        <p14:creationId xmlns:p14="http://schemas.microsoft.com/office/powerpoint/2010/main" val="1024086991"/>
-      </p:ext>
-    </p:extLst>
-  </p:cSld>
-  <p:clrMapOvr>
-    <a:masterClrMapping/>
-  </p:clrMapOvr>
-</p:notes>
-</file>
-
 <file path=ppt/slideLayouts/slideLayout1.xml><?xml version="1.0" encoding="utf-8"?>
 <p:sldLayout xmlns:a="http://schemas.openxmlformats.org/drawingml/2006/main" xmlns:r="http://schemas.openxmlformats.org/officeDocument/2006/relationships" xmlns:p="http://schemas.openxmlformats.org/presentationml/2006/main" preserve="1">
   <p:cSld name="DEFAULT">
@@ -3502,6 +3415,224 @@
                 <a:ea typeface="Arial" pitchFamily="34" charset="-122"/>
                 <a:cs typeface="Arial" pitchFamily="34" charset="-120"/>
               </a:rPr>
+              <a:t>What changed — prefill: start from chunk k, not chunk 0</a:t>
+            </a:r>
+          </a:p>
+        </p:txBody>
+      </p:sp>
+      <p:pic>
+        <p:nvPicPr>
+          <p:cNvPr id="4" name="Image 0" descr="preencoded.png">    </p:cNvPr>
+          <p:cNvPicPr>
+            <a:picLocks noChangeAspect="1"/>
+          </p:cNvPicPr>
+          <p:nvPr/>
+        </p:nvPicPr>
+        <p:blipFill>
+          <a:blip r:embed="rId2"/>
+          <a:stretch>
+            <a:fillRect/>
+          </a:stretch>
+        </p:blipFill>
+        <p:spPr>
+          <a:xfrm>
+            <a:off x="1371600" y="9746010"/>
+            <a:ext cx="2201912" cy="159990"/>
+          </a:xfrm>
+          <a:prstGeom prst="rect">
+            <a:avLst/>
+          </a:prstGeom>
+        </p:spPr>
+      </p:pic>
+      <p:pic>
+        <p:nvPicPr>
+          <p:cNvPr id="5" name="Picture 4" descr="diag_prefill.png"/>
+          <p:cNvPicPr>
+            <a:picLocks noChangeAspect="1"/>
+          </p:cNvPicPr>
+          <p:nvPr/>
+        </p:nvPicPr>
+        <p:blipFill>
+          <a:blip r:embed="rId3"/>
+          <a:stretch>
+            <a:fillRect/>
+          </a:stretch>
+        </p:blipFill>
+        <p:spPr>
+          <a:xfrm>
+            <a:off x="1344168" y="2331720"/>
+            <a:ext cx="15599663" cy="6309360"/>
+          </a:xfrm>
+          <a:prstGeom prst="rect">
+            <a:avLst/>
+          </a:prstGeom>
+        </p:spPr>
+      </p:pic>
+    </p:spTree>
+  </p:cSld>
+  <p:clrMapOvr>
+    <a:masterClrMapping/>
+  </p:clrMapOvr>
+</p:sld>
+</file>
+
+<file path=ppt/slides/slide21.xml><?xml version="1.0" encoding="utf-8"?>
+<p:sld xmlns:a="http://schemas.openxmlformats.org/drawingml/2006/main" xmlns:p="http://schemas.openxmlformats.org/presentationml/2006/main" xmlns:r="http://schemas.openxmlformats.org/officeDocument/2006/relationships">
+  <p:cSld>
+    <p:spTree>
+      <p:nvGrpSpPr>
+        <p:cNvPr id="1" name=""/>
+        <p:cNvGrpSpPr/>
+        <p:nvPr/>
+      </p:nvGrpSpPr>
+      <p:grpSpPr/>
+      <p:sp>
+        <p:nvSpPr>
+          <p:cNvPr id="2" name="Text 0"/>
+          <p:cNvSpPr/>
+          <p:nvPr/>
+        </p:nvSpPr>
+        <p:spPr>
+          <a:xfrm>
+            <a:off x="1341239" y="1528763"/>
+            <a:ext cx="17132677" cy="490538"/>
+          </a:xfrm>
+          <a:prstGeom prst="rect">
+            <a:avLst/>
+          </a:prstGeom>
+          <a:noFill/>
+          <a:ln/>
+        </p:spPr>
+        <p:txBody>
+          <a:bodyPr wrap="square" lIns="25400" tIns="25400" rIns="25400" bIns="25400" rtlCol="0" anchor="t">
+            <a:normAutofit/>
+          </a:bodyPr>
+          <a:lstStyle/>
+          <a:p>
+            <a:pPr algn="l" indent="0" marL="0">
+              <a:lnSpc>
+                <a:spcPct val="89655"/>
+              </a:lnSpc>
+              <a:buNone/>
+            </a:pPr>
+            <a:r>
+              <a:rPr lang="en-US" sz="5700" spc="-57" kern="0" dirty="0">
+                <a:solidFill>
+                  <a:srgbClr val="201F1D"/>
+                </a:solidFill>
+                <a:latin typeface="Arial" pitchFamily="34" charset="0"/>
+                <a:ea typeface="Arial" pitchFamily="34" charset="-122"/>
+                <a:cs typeface="Arial" pitchFamily="34" charset="-120"/>
+              </a:rPr>
+              <a:t>What changed — decode: retain the KV instead of rewinding</a:t>
+            </a:r>
+          </a:p>
+        </p:txBody>
+      </p:sp>
+      <p:pic>
+        <p:nvPicPr>
+          <p:cNvPr id="4" name="Image 0" descr="preencoded.png">    </p:cNvPr>
+          <p:cNvPicPr>
+            <a:picLocks noChangeAspect="1"/>
+          </p:cNvPicPr>
+          <p:nvPr/>
+        </p:nvPicPr>
+        <p:blipFill>
+          <a:blip r:embed="rId2"/>
+          <a:stretch>
+            <a:fillRect/>
+          </a:stretch>
+        </p:blipFill>
+        <p:spPr>
+          <a:xfrm>
+            <a:off x="1371600" y="9746010"/>
+            <a:ext cx="2201912" cy="159990"/>
+          </a:xfrm>
+          <a:prstGeom prst="rect">
+            <a:avLst/>
+          </a:prstGeom>
+        </p:spPr>
+      </p:pic>
+      <p:pic>
+        <p:nvPicPr>
+          <p:cNvPr id="5" name="Picture 4" descr="diag_decode.png"/>
+          <p:cNvPicPr>
+            <a:picLocks noChangeAspect="1"/>
+          </p:cNvPicPr>
+          <p:nvPr/>
+        </p:nvPicPr>
+        <p:blipFill>
+          <a:blip r:embed="rId3"/>
+          <a:stretch>
+            <a:fillRect/>
+          </a:stretch>
+        </p:blipFill>
+        <p:spPr>
+          <a:xfrm>
+            <a:off x="1344168" y="2331720"/>
+            <a:ext cx="15599663" cy="6309360"/>
+          </a:xfrm>
+          <a:prstGeom prst="rect">
+            <a:avLst/>
+          </a:prstGeom>
+        </p:spPr>
+      </p:pic>
+    </p:spTree>
+  </p:cSld>
+  <p:clrMapOvr>
+    <a:masterClrMapping/>
+  </p:clrMapOvr>
+</p:sld>
+</file>
+
+<file path=ppt/slides/slide22.xml><?xml version="1.0" encoding="utf-8"?>
+<p:sld xmlns:a="http://schemas.openxmlformats.org/drawingml/2006/main" xmlns:p="http://schemas.openxmlformats.org/presentationml/2006/main" xmlns:r="http://schemas.openxmlformats.org/officeDocument/2006/relationships">
+  <p:cSld>
+    <p:spTree>
+      <p:nvGrpSpPr>
+        <p:cNvPr id="1" name=""/>
+        <p:cNvGrpSpPr/>
+        <p:nvPr/>
+      </p:nvGrpSpPr>
+      <p:grpSpPr/>
+      <p:sp>
+        <p:nvSpPr>
+          <p:cNvPr id="2" name="Text 0"/>
+          <p:cNvSpPr/>
+          <p:nvPr/>
+        </p:nvSpPr>
+        <p:spPr>
+          <a:xfrm>
+            <a:off x="1341239" y="1528763"/>
+            <a:ext cx="17132677" cy="490538"/>
+          </a:xfrm>
+          <a:prstGeom prst="rect">
+            <a:avLst/>
+          </a:prstGeom>
+          <a:noFill/>
+          <a:ln/>
+        </p:spPr>
+        <p:txBody>
+          <a:bodyPr wrap="square" lIns="25400" tIns="25400" rIns="25400" bIns="25400" rtlCol="0" anchor="t">
+            <a:normAutofit/>
+          </a:bodyPr>
+          <a:lstStyle/>
+          <a:p>
+            <a:pPr algn="l" indent="0" marL="0">
+              <a:lnSpc>
+                <a:spcPct val="89655"/>
+              </a:lnSpc>
+              <a:buNone/>
+            </a:pPr>
+            <a:r>
+              <a:rPr lang="en-US" sz="5700" spc="-57" kern="0" dirty="0">
+                <a:solidFill>
+                  <a:srgbClr val="201F1D"/>
+                </a:solidFill>
+                <a:latin typeface="Arial" pitchFamily="34" charset="0"/>
+                <a:ea typeface="Arial" pitchFamily="34" charset="-122"/>
+                <a:cs typeface="Arial" pitchFamily="34" charset="-120"/>
+              </a:rPr>
               <a:t>Decode — the win is skipping whole steps, not making steps cheaper</a:t>
             </a:r>
           </a:p>
@@ -5484,281 +5615,6 @@
       <p:pic>
         <p:nvPicPr>
           <p:cNvPr id="4" name="Image 0" descr="preencoded.png">    </p:cNvPr>
-          <p:cNvPicPr>
-            <a:picLocks noChangeAspect="1"/>
-          </p:cNvPicPr>
-          <p:nvPr/>
-        </p:nvPicPr>
-        <p:blipFill>
-          <a:blip r:embed="rId1"/>
-          <a:stretch>
-            <a:fillRect/>
-          </a:stretch>
-        </p:blipFill>
-        <p:spPr>
-          <a:xfrm>
-            <a:off x="1371600" y="9746010"/>
-            <a:ext cx="2201912" cy="159990"/>
-          </a:xfrm>
-          <a:prstGeom prst="rect">
-            <a:avLst/>
-          </a:prstGeom>
-        </p:spPr>
-      </p:pic>
-    </p:spTree>
-  </p:cSld>
-  <p:clrMapOvr>
-    <a:masterClrMapping/>
-  </p:clrMapOvr>
-</p:sld>
-</file>
-
-<file path=ppt/slides/slide5.xml><?xml version="1.0" encoding="utf-8"?>
-<p:sld xmlns:a="http://schemas.openxmlformats.org/drawingml/2006/main" xmlns:r="http://schemas.openxmlformats.org/officeDocument/2006/relationships" xmlns:p="http://schemas.openxmlformats.org/presentationml/2006/main">
-  <p:cSld name="Slide 5">
-    <p:bg>
-      <p:bgPr>
-        <a:solidFill>
-          <a:srgbClr val="F3F2F2"/>
-        </a:solidFill>
-      </p:bgPr>
-    </p:bg>
-    <p:spTree>
-      <p:nvGrpSpPr>
-        <p:cNvPr id="1" name=""/>
-        <p:cNvGrpSpPr/>
-        <p:nvPr/>
-      </p:nvGrpSpPr>
-      <p:grpSpPr>
-        <a:xfrm>
-          <a:off x="0" y="0"/>
-          <a:ext cx="0" cy="0"/>
-          <a:chOff x="0" y="0"/>
-          <a:chExt cx="0" cy="0"/>
-        </a:xfrm>
-      </p:grpSpPr>
-      <p:sp>
-        <p:nvSpPr>
-          <p:cNvPr id="2" name="Text 0"/>
-          <p:cNvSpPr/>
-          <p:nvPr/>
-        </p:nvSpPr>
-        <p:spPr>
-          <a:xfrm>
-            <a:off x="1341239" y="1528763"/>
-            <a:ext cx="17132677" cy="490538"/>
-          </a:xfrm>
-          <a:prstGeom prst="rect">
-            <a:avLst/>
-          </a:prstGeom>
-          <a:noFill/>
-          <a:ln/>
-        </p:spPr>
-        <p:txBody>
-          <a:bodyPr wrap="square" lIns="25400" tIns="25400" rIns="25400" bIns="25400" rtlCol="0" anchor="t">
-            <a:normAutofit/>
-          </a:bodyPr>
-          <a:lstStyle/>
-          <a:p>
-            <a:pPr algn="l" indent="0" marL="0">
-              <a:lnSpc>
-                <a:spcPct val="89655"/>
-              </a:lnSpc>
-              <a:buNone/>
-            </a:pPr>
-            <a:r>
-              <a:rPr lang="en-US" sz="5700" spc="-57" kern="0" dirty="0">
-                <a:solidFill>
-                  <a:srgbClr val="201F1D"/>
-                </a:solidFill>
-                <a:latin typeface="Arial" pitchFamily="34" charset="0"/>
-                <a:ea typeface="Arial" pitchFamily="34" charset="-122"/>
-                <a:cs typeface="Arial" pitchFamily="34" charset="-120"/>
-              </a:rPr>
-              <a:t>What actually changed</a:t>
-            </a:r>
-          </a:p>
-        </p:txBody>
-      </p:sp>
-      <p:sp>
-        <p:nvSpPr>
-          <p:cNvPr id="3" name="Text 1"/>
-          <p:cNvSpPr/>
-          <p:nvPr/>
-        </p:nvSpPr>
-        <p:spPr>
-          <a:xfrm>
-            <a:off x="1371600" y="3181350"/>
-            <a:ext cx="8004810" cy="323850"/>
-          </a:xfrm>
-          <a:prstGeom prst="rect">
-            <a:avLst/>
-          </a:prstGeom>
-          <a:noFill/>
-          <a:ln/>
-        </p:spPr>
-        <p:txBody>
-          <a:bodyPr wrap="square" lIns="25400" tIns="25400" rIns="25400" bIns="25400" rtlCol="0" anchor="t">
-            <a:normAutofit/>
-          </a:bodyPr>
-          <a:lstStyle/>
-          <a:p>
-            <a:pPr algn="l" indent="0" marL="0">
-              <a:lnSpc>
-                <a:spcPct val="94545"/>
-              </a:lnSpc>
-              <a:buNone/>
-            </a:pPr>
-            <a:r>
-              <a:rPr lang="en-US" sz="3600" spc="-54" kern="0" dirty="0">
-                <a:solidFill>
-                  <a:srgbClr val="201F1D"/>
-                </a:solidFill>
-                <a:latin typeface="Arial" pitchFamily="34" charset="0"/>
-                <a:ea typeface="Arial" pitchFamily="34" charset="-122"/>
-                <a:cs typeface="Arial" pitchFamily="34" charset="-120"/>
-              </a:rPr>
-              <a:t>Prefill — start from chunk k, not chunk 0</a:t>
-            </a:r>
-          </a:p>
-        </p:txBody>
-      </p:sp>
-      <p:sp>
-        <p:nvSpPr>
-          <p:cNvPr id="4" name="Text 2"/>
-          <p:cNvSpPr/>
-          <p:nvPr/>
-        </p:nvSpPr>
-        <p:spPr>
-          <a:xfrm>
-            <a:off x="1371600" y="3762375"/>
-            <a:ext cx="7495413" cy="1724025"/>
-          </a:xfrm>
-          <a:prstGeom prst="rect">
-            <a:avLst/>
-          </a:prstGeom>
-          <a:noFill/>
-          <a:ln/>
-        </p:spPr>
-        <p:txBody>
-          <a:bodyPr wrap="square" lIns="25400" tIns="25400" rIns="25400" bIns="25400" rtlCol="0" anchor="t">
-            <a:normAutofit/>
-          </a:bodyPr>
-          <a:lstStyle/>
-          <a:p>
-            <a:pPr algn="just" indent="0" marL="0">
-              <a:lnSpc>
-                <a:spcPct val="152941"/>
-              </a:lnSpc>
-              <a:buNone/>
-            </a:pPr>
-            <a:r>
-              <a:rPr lang="en-US" sz="2250" dirty="0">
-                <a:solidFill>
-                  <a:srgbClr val="201F1D"/>
-                </a:solidFill>
-                <a:latin typeface="Arial" pitchFamily="34" charset="0"/>
-                <a:ea typeface="Arial" pitchFamily="34" charset="-122"/>
-                <a:cs typeface="Arial" pitchFamily="34" charset="-120"/>
-              </a:rPr>
-              <a:t>Prefill processes a prompt in fixed-size chunks. The key observation is that the K/V banks already physically hold the previous request's chunks — the per-request reset only rewound a counter, it never cleared the data.
-So a request now carries a start_chunk: keep the resident chunks 0..k-1, compute only the suffix, and have the host stream only the suffix tokens.
-Constraint: the shared prefix must be chunk-aligned, otherwise the boundary chunk has to be recomputed.</a:t>
-            </a:r>
-          </a:p>
-        </p:txBody>
-      </p:sp>
-      <p:sp>
-        <p:nvSpPr>
-          <p:cNvPr id="5" name="Text 3"/>
-          <p:cNvSpPr/>
-          <p:nvPr/>
-        </p:nvSpPr>
-        <p:spPr>
-          <a:xfrm>
-            <a:off x="9639300" y="3181350"/>
-            <a:ext cx="8004810" cy="323850"/>
-          </a:xfrm>
-          <a:prstGeom prst="rect">
-            <a:avLst/>
-          </a:prstGeom>
-          <a:noFill/>
-          <a:ln/>
-        </p:spPr>
-        <p:txBody>
-          <a:bodyPr wrap="square" lIns="25400" tIns="25400" rIns="25400" bIns="25400" rtlCol="0" anchor="t">
-            <a:normAutofit/>
-          </a:bodyPr>
-          <a:lstStyle/>
-          <a:p>
-            <a:pPr algn="l" indent="0" marL="0">
-              <a:lnSpc>
-                <a:spcPct val="94545"/>
-              </a:lnSpc>
-              <a:buNone/>
-            </a:pPr>
-            <a:r>
-              <a:rPr lang="en-US" sz="3600" spc="-54" kern="0" dirty="0">
-                <a:solidFill>
-                  <a:srgbClr val="201F1D"/>
-                </a:solidFill>
-                <a:latin typeface="Arial" pitchFamily="34" charset="0"/>
-                <a:ea typeface="Arial" pitchFamily="34" charset="-122"/>
-                <a:cs typeface="Arial" pitchFamily="34" charset="-120"/>
-              </a:rPr>
-              <a:t>Decode — retain instead of rewind</a:t>
-            </a:r>
-          </a:p>
-        </p:txBody>
-      </p:sp>
-      <p:sp>
-        <p:nvSpPr>
-          <p:cNvPr id="6" name="Text 4"/>
-          <p:cNvSpPr/>
-          <p:nvPr/>
-        </p:nvSpPr>
-        <p:spPr>
-          <a:xfrm>
-            <a:off x="9639300" y="3762375"/>
-            <a:ext cx="7495413" cy="1228725"/>
-          </a:xfrm>
-          <a:prstGeom prst="rect">
-            <a:avLst/>
-          </a:prstGeom>
-          <a:noFill/>
-          <a:ln/>
-        </p:spPr>
-        <p:txBody>
-          <a:bodyPr wrap="square" lIns="25400" tIns="25400" rIns="25400" bIns="25400" rtlCol="0" anchor="t">
-            <a:normAutofit/>
-          </a:bodyPr>
-          <a:lstStyle/>
-          <a:p>
-            <a:pPr algn="just" indent="0" marL="0">
-              <a:lnSpc>
-                <a:spcPct val="152941"/>
-              </a:lnSpc>
-              <a:buNone/>
-            </a:pPr>
-            <a:r>
-              <a:rPr lang="en-US" sz="2250" dirty="0">
-                <a:solidFill>
-                  <a:srgbClr val="201F1D"/>
-                </a:solidFill>
-                <a:latin typeface="Arial" pitchFamily="34" charset="0"/>
-                <a:ea typeface="Arial" pitchFamily="34" charset="-122"/>
-                <a:cs typeface="Arial" pitchFamily="34" charset="-120"/>
-              </a:rPr>
-              <a:t>The same idea, the same mechanism. Decode's per-request reset rewound the KV write counter, throwing away the previous request's KV while it was still sitting in SRAM.
-Retain gates that rewind: continue the position encoding, and recompute the remaining steps from the retained length.
-The host then stops re-shipping the prefix each round and sends a metadata-only message instead.</a:t>
-            </a:r>
-          </a:p>
-        </p:txBody>
-      </p:sp>
-      <p:pic>
-        <p:nvPicPr>
-          <p:cNvPr id="7" name="Image 0" descr="preencoded.png">    </p:cNvPr>
           <p:cNvPicPr>
             <a:picLocks noChangeAspect="1"/>
           </p:cNvPicPr>

</xml_diff>